<commit_message>
deck: kids-action photos on title slide (full-bleed right panel) and closing slide (dojo band) — sweat & energy added
</commit_message>
<xml_diff>
--- a/NextPlay-Kids-Investor-Pitch.pptx
+++ b/NextPlay-Kids-Investor-Pitch.pptx
@@ -3657,99 +3657,33 @@
         <p:nvPr/>
       </p:nvGrpSpPr>
       <p:grpSpPr/>
-      <p:sp>
-        <p:nvSpPr>
-          <p:cNvPr id="2" name="Rounded Rectangle 1"/>
-          <p:cNvSpPr/>
-          <p:nvPr/>
-        </p:nvSpPr>
-        <p:spPr>
-          <a:xfrm>
-            <a:off x="-1097280" y="-1463040"/>
-            <a:ext cx="5669280" cy="4023360"/>
-          </a:xfrm>
-          <a:prstGeom prst="roundRect">
-            <a:avLst>
-              <a:gd name="adj" fmla="val 7000"/>
-            </a:avLst>
-          </a:prstGeom>
-          <a:solidFill>
-            <a:srgbClr val="101B33"/>
-          </a:solidFill>
-          <a:ln>
-            <a:noFill/>
-          </a:ln>
-          <a:effectLst/>
-        </p:spPr>
-        <p:style>
-          <a:lnRef idx="1">
-            <a:schemeClr val="accent1"/>
-          </a:lnRef>
-          <a:fillRef idx="3">
-            <a:schemeClr val="accent1"/>
-          </a:fillRef>
-          <a:effectRef idx="2">
-            <a:schemeClr val="accent1"/>
-          </a:effectRef>
-          <a:fontRef idx="minor">
-            <a:schemeClr val="lt1"/>
-          </a:fontRef>
-        </p:style>
-        <p:txBody>
-          <a:bodyPr rtlCol="0" anchor="ctr"/>
-          <a:lstStyle/>
-          <a:p>
-            <a:pPr algn="ctr"/>
-          </a:p>
-        </p:txBody>
-      </p:sp>
-      <p:sp>
-        <p:nvSpPr>
-          <p:cNvPr id="3" name="Rectangle 2"/>
-          <p:cNvSpPr/>
-          <p:nvPr/>
-        </p:nvSpPr>
-        <p:spPr>
-          <a:xfrm>
-            <a:off x="8412480" y="-1280160"/>
-            <a:ext cx="5852160" cy="5852160"/>
-          </a:xfrm>
-          <a:prstGeom prst="rect">
-            <a:avLst/>
-          </a:prstGeom>
-          <a:solidFill>
-            <a:srgbClr val="101B33"/>
-          </a:solidFill>
-          <a:ln>
-            <a:noFill/>
-          </a:ln>
-          <a:effectLst/>
-        </p:spPr>
-        <p:style>
-          <a:lnRef idx="1">
-            <a:schemeClr val="accent1"/>
-          </a:lnRef>
-          <a:fillRef idx="3">
-            <a:schemeClr val="accent1"/>
-          </a:fillRef>
-          <a:effectRef idx="2">
-            <a:schemeClr val="accent1"/>
-          </a:effectRef>
-          <a:fontRef idx="minor">
-            <a:schemeClr val="lt1"/>
-          </a:fontRef>
-        </p:style>
-        <p:txBody>
-          <a:bodyPr rtlCol="0" anchor="ctr"/>
-          <a:lstStyle/>
-          <a:p>
-            <a:pPr algn="ctr"/>
-          </a:p>
-        </p:txBody>
-      </p:sp>
-      <p:sp>
-        <p:nvSpPr>
-          <p:cNvPr id="4" name="TextBox 3"/>
+      <p:pic>
+        <p:nvPicPr>
+          <p:cNvPr id="2" name="Picture 1" descr="hero-football-ppt.jpg"/>
+          <p:cNvPicPr>
+            <a:picLocks noChangeAspect="1"/>
+          </p:cNvPicPr>
+          <p:nvPr/>
+        </p:nvPicPr>
+        <p:blipFill>
+          <a:blip r:embed="rId2"/>
+          <a:stretch>
+            <a:fillRect/>
+          </a:stretch>
+        </p:blipFill>
+        <p:spPr>
+          <a:xfrm>
+            <a:off x="6720840" y="0"/>
+            <a:ext cx="5470855" cy="4480560"/>
+          </a:xfrm>
+          <a:prstGeom prst="rect">
+            <a:avLst/>
+          </a:prstGeom>
+        </p:spPr>
+      </p:pic>
+      <p:sp>
+        <p:nvSpPr>
+          <p:cNvPr id="3" name="TextBox 2"/>
           <p:cNvSpPr txBox="1"/>
           <p:nvPr/>
         </p:nvSpPr>
@@ -3791,14 +3725,75 @@
       </p:sp>
       <p:sp>
         <p:nvSpPr>
+          <p:cNvPr id="4" name="TextBox 3"/>
+          <p:cNvSpPr txBox="1"/>
+          <p:nvPr/>
+        </p:nvSpPr>
+        <p:spPr>
+          <a:xfrm>
+            <a:off x="594360" y="1417320"/>
+            <a:ext cx="5943600" cy="2194560"/>
+          </a:xfrm>
+          <a:prstGeom prst="rect">
+            <a:avLst/>
+          </a:prstGeom>
+          <a:noFill/>
+        </p:spPr>
+        <p:txBody>
+          <a:bodyPr wrap="square" lIns="0" rIns="0" tIns="0" bIns="0" anchor="t">
+            <a:spAutoFit/>
+          </a:bodyPr>
+          <a:lstStyle/>
+          <a:p>
+            <a:pPr algn="l">
+              <a:lnSpc>
+                <a:spcPct val="105000"/>
+              </a:lnSpc>
+              <a:spcAft>
+                <a:spcPts val="600"/>
+              </a:spcAft>
+            </a:pPr>
+            <a:r>
+              <a:rPr sz="4000" b="1" i="0">
+                <a:solidFill>
+                  <a:srgbClr val="F2F4F8"/>
+                </a:solidFill>
+                <a:latin typeface="Segoe UI"/>
+              </a:rPr>
+              <a:t>Every child deserves</a:t>
+            </a:r>
+          </a:p>
+          <a:p>
+            <a:pPr algn="l">
+              <a:lnSpc>
+                <a:spcPct val="105000"/>
+              </a:lnSpc>
+              <a:spcAft>
+                <a:spcPts val="600"/>
+              </a:spcAft>
+            </a:pPr>
+            <a:r>
+              <a:rPr sz="4000" b="1" i="0">
+                <a:solidFill>
+                  <a:srgbClr val="00E676"/>
+                </a:solidFill>
+                <a:latin typeface="Segoe UI"/>
+              </a:rPr>
+              <a:t>a place to play.</a:t>
+            </a:r>
+          </a:p>
+        </p:txBody>
+      </p:sp>
+      <p:sp>
+        <p:nvSpPr>
           <p:cNvPr id="5" name="TextBox 4"/>
           <p:cNvSpPr txBox="1"/>
           <p:nvPr/>
         </p:nvSpPr>
         <p:spPr>
           <a:xfrm>
-            <a:off x="594360" y="1417320"/>
-            <a:ext cx="10607040" cy="1554480"/>
+            <a:off x="640080" y="3310128"/>
+            <a:ext cx="5760720" cy="1097280"/>
           </a:xfrm>
           <a:prstGeom prst="rect">
             <a:avLst/>
@@ -3813,67 +3808,6 @@
           <a:p>
             <a:pPr algn="l">
               <a:lnSpc>
-                <a:spcPct val="102000"/>
-              </a:lnSpc>
-              <a:spcAft>
-                <a:spcPts val="600"/>
-              </a:spcAft>
-            </a:pPr>
-            <a:r>
-              <a:rPr sz="4800" b="1" i="0">
-                <a:solidFill>
-                  <a:srgbClr val="F2F4F8"/>
-                </a:solidFill>
-                <a:latin typeface="Segoe UI"/>
-              </a:rPr>
-              <a:t>Every child deserves</a:t>
-            </a:r>
-          </a:p>
-          <a:p>
-            <a:pPr algn="l">
-              <a:lnSpc>
-                <a:spcPct val="102000"/>
-              </a:lnSpc>
-              <a:spcAft>
-                <a:spcPts val="600"/>
-              </a:spcAft>
-            </a:pPr>
-            <a:r>
-              <a:rPr sz="4800" b="1" i="0">
-                <a:solidFill>
-                  <a:srgbClr val="00E676"/>
-                </a:solidFill>
-                <a:latin typeface="Segoe UI"/>
-              </a:rPr>
-              <a:t>a place to play.</a:t>
-            </a:r>
-          </a:p>
-        </p:txBody>
-      </p:sp>
-      <p:sp>
-        <p:nvSpPr>
-          <p:cNvPr id="6" name="TextBox 5"/>
-          <p:cNvSpPr txBox="1"/>
-          <p:nvPr/>
-        </p:nvSpPr>
-        <p:spPr>
-          <a:xfrm>
-            <a:off x="640080" y="3310128"/>
-            <a:ext cx="8412480" cy="914400"/>
-          </a:xfrm>
-          <a:prstGeom prst="rect">
-            <a:avLst/>
-          </a:prstGeom>
-          <a:noFill/>
-        </p:spPr>
-        <p:txBody>
-          <a:bodyPr wrap="square" lIns="0" rIns="0" tIns="0" bIns="0" anchor="t">
-            <a:spAutoFit/>
-          </a:bodyPr>
-          <a:lstStyle/>
-          <a:p>
-            <a:pPr algn="l">
-              <a:lnSpc>
                 <a:spcPct val="125000"/>
               </a:lnSpc>
               <a:spcAft>
@@ -3881,7 +3815,7 @@
               </a:spcAft>
             </a:pPr>
             <a:r>
-              <a:rPr sz="1700" b="0" i="0">
+              <a:rPr sz="1550" b="0" i="0">
                 <a:solidFill>
                   <a:srgbClr val="9AA3B5"/>
                 </a:solidFill>
@@ -3894,7 +3828,7 @@
       </p:sp>
       <p:sp>
         <p:nvSpPr>
-          <p:cNvPr id="7" name="Rounded Rectangle 6"/>
+          <p:cNvPr id="6" name="Rounded Rectangle 5"/>
           <p:cNvSpPr/>
           <p:nvPr/>
         </p:nvSpPr>
@@ -3942,7 +3876,7 @@
       </p:sp>
       <p:sp>
         <p:nvSpPr>
-          <p:cNvPr id="8" name="TextBox 7"/>
+          <p:cNvPr id="7" name="TextBox 6"/>
           <p:cNvSpPr txBox="1"/>
           <p:nvPr/>
         </p:nvSpPr>
@@ -3984,7 +3918,7 @@
       </p:sp>
       <p:sp>
         <p:nvSpPr>
-          <p:cNvPr id="9" name="TextBox 8"/>
+          <p:cNvPr id="8" name="TextBox 7"/>
           <p:cNvSpPr txBox="1"/>
           <p:nvPr/>
         </p:nvSpPr>
@@ -4026,7 +3960,7 @@
       </p:sp>
       <p:sp>
         <p:nvSpPr>
-          <p:cNvPr id="10" name="Rounded Rectangle 9"/>
+          <p:cNvPr id="9" name="Rounded Rectangle 8"/>
           <p:cNvSpPr/>
           <p:nvPr/>
         </p:nvSpPr>
@@ -4074,7 +4008,7 @@
       </p:sp>
       <p:sp>
         <p:nvSpPr>
-          <p:cNvPr id="11" name="TextBox 10"/>
+          <p:cNvPr id="10" name="TextBox 9"/>
           <p:cNvSpPr txBox="1"/>
           <p:nvPr/>
         </p:nvSpPr>
@@ -4116,7 +4050,7 @@
       </p:sp>
       <p:sp>
         <p:nvSpPr>
-          <p:cNvPr id="12" name="TextBox 11"/>
+          <p:cNvPr id="11" name="TextBox 10"/>
           <p:cNvSpPr txBox="1"/>
           <p:nvPr/>
         </p:nvSpPr>
@@ -4158,7 +4092,7 @@
       </p:sp>
       <p:sp>
         <p:nvSpPr>
-          <p:cNvPr id="13" name="Rounded Rectangle 12"/>
+          <p:cNvPr id="12" name="Rounded Rectangle 11"/>
           <p:cNvSpPr/>
           <p:nvPr/>
         </p:nvSpPr>
@@ -4206,7 +4140,7 @@
       </p:sp>
       <p:sp>
         <p:nvSpPr>
-          <p:cNvPr id="14" name="TextBox 13"/>
+          <p:cNvPr id="13" name="TextBox 12"/>
           <p:cNvSpPr txBox="1"/>
           <p:nvPr/>
         </p:nvSpPr>
@@ -4248,7 +4182,7 @@
       </p:sp>
       <p:sp>
         <p:nvSpPr>
-          <p:cNvPr id="15" name="TextBox 14"/>
+          <p:cNvPr id="14" name="TextBox 13"/>
           <p:cNvSpPr txBox="1"/>
           <p:nvPr/>
         </p:nvSpPr>
@@ -4290,7 +4224,7 @@
       </p:sp>
       <p:sp>
         <p:nvSpPr>
-          <p:cNvPr id="16" name="Rounded Rectangle 15"/>
+          <p:cNvPr id="15" name="Rounded Rectangle 14"/>
           <p:cNvSpPr/>
           <p:nvPr/>
         </p:nvSpPr>
@@ -4338,7 +4272,7 @@
       </p:sp>
       <p:sp>
         <p:nvSpPr>
-          <p:cNvPr id="17" name="TextBox 16"/>
+          <p:cNvPr id="16" name="TextBox 15"/>
           <p:cNvSpPr txBox="1"/>
           <p:nvPr/>
         </p:nvSpPr>
@@ -4380,7 +4314,7 @@
       </p:sp>
       <p:sp>
         <p:nvSpPr>
-          <p:cNvPr id="18" name="TextBox 17"/>
+          <p:cNvPr id="17" name="TextBox 16"/>
           <p:cNvSpPr txBox="1"/>
           <p:nvPr/>
         </p:nvSpPr>
@@ -4422,7 +4356,7 @@
       </p:sp>
       <p:sp>
         <p:nvSpPr>
-          <p:cNvPr id="19" name="TextBox 18"/>
+          <p:cNvPr id="18" name="TextBox 17"/>
           <p:cNvSpPr txBox="1"/>
           <p:nvPr/>
         </p:nvSpPr>
@@ -5496,22 +5430,46 @@
         <p:nvPr/>
       </p:nvGrpSpPr>
       <p:grpSpPr/>
-      <p:sp>
-        <p:nvSpPr>
-          <p:cNvPr id="2" name="Rectangle 1"/>
+      <p:pic>
+        <p:nvPicPr>
+          <p:cNvPr id="2" name="Picture 1" descr="dojo-close.jpg"/>
+          <p:cNvPicPr>
+            <a:picLocks noChangeAspect="1"/>
+          </p:cNvPicPr>
+          <p:nvPr/>
+        </p:nvPicPr>
+        <p:blipFill>
+          <a:blip r:embed="rId2"/>
+          <a:stretch>
+            <a:fillRect/>
+          </a:stretch>
+        </p:blipFill>
+        <p:spPr>
+          <a:xfrm>
+            <a:off x="0" y="4041648"/>
+            <a:ext cx="12191695" cy="2816352"/>
+          </a:xfrm>
+          <a:prstGeom prst="rect">
+            <a:avLst/>
+          </a:prstGeom>
+        </p:spPr>
+      </p:pic>
+      <p:sp>
+        <p:nvSpPr>
+          <p:cNvPr id="3" name="Rectangle 2"/>
           <p:cNvSpPr/>
           <p:nvPr/>
         </p:nvSpPr>
         <p:spPr>
           <a:xfrm>
-            <a:off x="-1280160" y="4206240"/>
-            <a:ext cx="14630400" cy="4206240"/>
+            <a:off x="0" y="4041648"/>
+            <a:ext cx="12191695" cy="457200"/>
           </a:xfrm>
           <a:prstGeom prst="rect">
             <a:avLst/>
           </a:prstGeom>
           <a:solidFill>
-            <a:srgbClr val="101B33"/>
+            <a:srgbClr val="0A1128"/>
           </a:solidFill>
           <a:ln>
             <a:noFill/>
@@ -5542,13 +5500,13 @@
       </p:sp>
       <p:sp>
         <p:nvSpPr>
-          <p:cNvPr id="3" name="TextBox 2"/>
-          <p:cNvSpPr txBox="1"/>
-          <p:nvPr/>
-        </p:nvSpPr>
-        <p:spPr>
-          <a:xfrm>
-            <a:off x="822960" y="1828800"/>
+          <p:cNvPr id="4" name="TextBox 3"/>
+          <p:cNvSpPr txBox="1"/>
+          <p:nvPr/>
+        </p:nvSpPr>
+        <p:spPr>
+          <a:xfrm>
+            <a:off x="822960" y="1280160"/>
             <a:ext cx="10515600" cy="1737360"/>
           </a:xfrm>
           <a:prstGeom prst="rect">
@@ -5603,14 +5561,14 @@
       </p:sp>
       <p:sp>
         <p:nvSpPr>
-          <p:cNvPr id="4" name="TextBox 3"/>
-          <p:cNvSpPr txBox="1"/>
-          <p:nvPr/>
-        </p:nvSpPr>
-        <p:spPr>
-          <a:xfrm>
-            <a:off x="822960" y="3977639"/>
-            <a:ext cx="10058400" cy="1463040"/>
+          <p:cNvPr id="5" name="TextBox 4"/>
+          <p:cNvSpPr txBox="1"/>
+          <p:nvPr/>
+        </p:nvSpPr>
+        <p:spPr>
+          <a:xfrm>
+            <a:off x="822960" y="3063240"/>
+            <a:ext cx="10058400" cy="914400"/>
           </a:xfrm>
           <a:prstGeom prst="rect">
             <a:avLst/>
@@ -5683,13 +5641,13 @@
       </p:sp>
       <p:sp>
         <p:nvSpPr>
-          <p:cNvPr id="5" name="TextBox 4"/>
-          <p:cNvSpPr txBox="1"/>
-          <p:nvPr/>
-        </p:nvSpPr>
-        <p:spPr>
-          <a:xfrm>
-            <a:off x="822960" y="6263640"/>
+          <p:cNvPr id="6" name="TextBox 5"/>
+          <p:cNvSpPr txBox="1"/>
+          <p:nvPr/>
+        </p:nvSpPr>
+        <p:spPr>
+          <a:xfrm>
+            <a:off x="822960" y="6446520"/>
             <a:ext cx="10058400" cy="320040"/>
           </a:xfrm>
           <a:prstGeom prst="rect">

</xml_diff>